<commit_message>
BRD-04 Collections screenshots retaken in the BDO style-guide presentation on a fresh seed stack: 102 images; FRS, guide deck, sign-off workbook and UX documents 07 to 09 rebuilt at v2.0; capture widens the window for a list that scrolls sideways in its card and grows it to show a dialog taller than the window
</commit_message>
<xml_diff>
--- a/docs/deliverables/out/Drop-1_Transactional/BRD-04_Collections/01_BIBS_GuideDeck_BRD-04_Collections_v2.0.pptx
+++ b/docs/deliverables/out/Drop-1_Transactional/BRD-04_Collections/01_BIBS_GuideDeck_BRD-04_Collections_v2.0.pptx
@@ -10968,8 +10968,8 @@
         </p:blipFill>
         <p:spPr>
           <a:xfrm>
-            <a:off x="1959352" y="1325880"/>
-            <a:ext cx="2588622" cy="1874520"/>
+            <a:off x="1842195" y="1325880"/>
+            <a:ext cx="2822937" cy="1874520"/>
           </a:xfrm>
           <a:prstGeom prst="rect">
             <a:avLst/>
@@ -11032,8 +11032,8 @@
         </p:blipFill>
         <p:spPr>
           <a:xfrm>
-            <a:off x="7615905" y="1325880"/>
-            <a:ext cx="2644250" cy="1874520"/>
+            <a:off x="7579817" y="1325880"/>
+            <a:ext cx="2716426" cy="1874520"/>
           </a:xfrm>
           <a:prstGeom prst="rect">
             <a:avLst/>
@@ -11160,8 +11160,8 @@
         </p:blipFill>
         <p:spPr>
           <a:xfrm>
-            <a:off x="7615905" y="3566160"/>
-            <a:ext cx="2644250" cy="1874520"/>
+            <a:off x="7109305" y="3566160"/>
+            <a:ext cx="3657451" cy="1874520"/>
           </a:xfrm>
           <a:prstGeom prst="rect">
             <a:avLst/>

</xml_diff>